<commit_message>
Sync from private @ 634b255
</commit_message>
<xml_diff>
--- a/docs/Foreman_Deck.pptx
+++ b/docs/Foreman_Deck.pptx
@@ -6173,39 +6173,15 @@
           </a:p>
         </p:txBody>
       </p:sp>
-      <p:pic>
-        <p:nvPicPr>
-          <p:cNvPr id="5" name="Picture 4" descr="deck-01-top.png"/>
-          <p:cNvPicPr>
-            <a:picLocks noChangeAspect="1"/>
-          </p:cNvPicPr>
-          <p:nvPr/>
-        </p:nvPicPr>
-        <p:blipFill>
-          <a:blip r:embed="rId2"/>
-          <a:stretch>
-            <a:fillRect/>
-          </a:stretch>
-        </p:blipFill>
-        <p:spPr>
-          <a:xfrm>
-            <a:off x="4693158" y="1417320"/>
-            <a:ext cx="2805379" cy="3566160"/>
-          </a:xfrm>
-          <a:prstGeom prst="rect">
-            <a:avLst/>
-          </a:prstGeom>
-        </p:spPr>
-      </p:pic>
-      <p:sp>
-        <p:nvSpPr>
-          <p:cNvPr id="6" name="TextBox 5"/>
+      <p:sp>
+        <p:nvSpPr>
+          <p:cNvPr id="5" name="TextBox 4"/>
           <p:cNvSpPr txBox="1"/>
           <p:nvPr/>
         </p:nvSpPr>
         <p:spPr>
           <a:xfrm>
-            <a:off x="777240" y="5166360"/>
+            <a:off x="777240" y="5943600"/>
             <a:ext cx="10607040" cy="914400"/>
           </a:xfrm>
           <a:prstGeom prst="rect">
@@ -6890,39 +6866,15 @@
           </a:p>
         </p:txBody>
       </p:sp>
-      <p:pic>
-        <p:nvPicPr>
-          <p:cNvPr id="5" name="Picture 4" descr="deck-04-library.png"/>
-          <p:cNvPicPr>
-            <a:picLocks noChangeAspect="1"/>
-          </p:cNvPicPr>
-          <p:nvPr/>
-        </p:nvPicPr>
-        <p:blipFill>
-          <a:blip r:embed="rId2"/>
-          <a:stretch>
-            <a:fillRect/>
-          </a:stretch>
-        </p:blipFill>
-        <p:spPr>
-          <a:xfrm>
-            <a:off x="4693158" y="1417320"/>
-            <a:ext cx="2805379" cy="3566160"/>
-          </a:xfrm>
-          <a:prstGeom prst="rect">
-            <a:avLst/>
-          </a:prstGeom>
-        </p:spPr>
-      </p:pic>
-      <p:sp>
-        <p:nvSpPr>
-          <p:cNvPr id="6" name="TextBox 5"/>
+      <p:sp>
+        <p:nvSpPr>
+          <p:cNvPr id="5" name="TextBox 4"/>
           <p:cNvSpPr txBox="1"/>
           <p:nvPr/>
         </p:nvSpPr>
         <p:spPr>
           <a:xfrm>
-            <a:off x="777240" y="5166360"/>
+            <a:off x="777240" y="5943600"/>
             <a:ext cx="10607040" cy="914400"/>
           </a:xfrm>
           <a:prstGeom prst="rect">
@@ -7098,39 +7050,15 @@
           </a:p>
         </p:txBody>
       </p:sp>
-      <p:pic>
-        <p:nvPicPr>
-          <p:cNvPr id="5" name="Picture 4" descr="deck-02-loops.png"/>
-          <p:cNvPicPr>
-            <a:picLocks noChangeAspect="1"/>
-          </p:cNvPicPr>
-          <p:nvPr/>
-        </p:nvPicPr>
-        <p:blipFill>
-          <a:blip r:embed="rId2"/>
-          <a:stretch>
-            <a:fillRect/>
-          </a:stretch>
-        </p:blipFill>
-        <p:spPr>
-          <a:xfrm>
-            <a:off x="4693158" y="1417320"/>
-            <a:ext cx="2805379" cy="3566160"/>
-          </a:xfrm>
-          <a:prstGeom prst="rect">
-            <a:avLst/>
-          </a:prstGeom>
-        </p:spPr>
-      </p:pic>
-      <p:sp>
-        <p:nvSpPr>
-          <p:cNvPr id="6" name="TextBox 5"/>
+      <p:sp>
+        <p:nvSpPr>
+          <p:cNvPr id="5" name="TextBox 4"/>
           <p:cNvSpPr txBox="1"/>
           <p:nvPr/>
         </p:nvSpPr>
         <p:spPr>
           <a:xfrm>
-            <a:off x="777240" y="5166360"/>
+            <a:off x="777240" y="5943600"/>
             <a:ext cx="10607040" cy="914400"/>
           </a:xfrm>
           <a:prstGeom prst="rect">
@@ -7306,39 +7234,15 @@
           </a:p>
         </p:txBody>
       </p:sp>
-      <p:pic>
-        <p:nvPicPr>
-          <p:cNvPr id="5" name="Picture 4" descr="deck-03-repo.png"/>
-          <p:cNvPicPr>
-            <a:picLocks noChangeAspect="1"/>
-          </p:cNvPicPr>
-          <p:nvPr/>
-        </p:nvPicPr>
-        <p:blipFill>
-          <a:blip r:embed="rId2"/>
-          <a:stretch>
-            <a:fillRect/>
-          </a:stretch>
-        </p:blipFill>
-        <p:spPr>
-          <a:xfrm>
-            <a:off x="4693158" y="1417320"/>
-            <a:ext cx="2805379" cy="3566160"/>
-          </a:xfrm>
-          <a:prstGeom prst="rect">
-            <a:avLst/>
-          </a:prstGeom>
-        </p:spPr>
-      </p:pic>
-      <p:sp>
-        <p:nvSpPr>
-          <p:cNvPr id="6" name="TextBox 5"/>
+      <p:sp>
+        <p:nvSpPr>
+          <p:cNvPr id="5" name="TextBox 4"/>
           <p:cNvSpPr txBox="1"/>
           <p:nvPr/>
         </p:nvSpPr>
         <p:spPr>
           <a:xfrm>
-            <a:off x="777240" y="5166360"/>
+            <a:off x="777240" y="5943600"/>
             <a:ext cx="10607040" cy="914400"/>
           </a:xfrm>
           <a:prstGeom prst="rect">

</xml_diff>